<commit_message>
Find PowerPoint titles in text boxes and keep bullets and numbering
Paragraphs now follow their own bullet settings: bullet characters become
"- " items, auto-numbering becomes "1." items, and "no bullet" stays a
paragraph; body placeholders still bullet by default. Nested items are
indented under their parent's text so renderers keep the nesting.

Slides without a title placeholder take the topmost text box as the
title when it is one short line and nothing is set larger, or else the
single short line set in the largest type, instead of "Slide N".

Co-Authored-By: Claude Opus 5.5 <noreply@anthropic.com>
</commit_message>
<xml_diff>
--- a/tests/fixtures/deck.pptx
+++ b/tests/fixtures/deck.pptx
@@ -9,9 +9,11 @@
     <p:sldId id="257" r:id="rId3"/>
     <p:sldId id="258" r:id="rId4"/>
     <p:sldId id="259" r:id="rId5"/>
+    <p:sldId id="260" r:id="rId6"/>
+    <p:sldId id="261" r:id="rId7"/>
   </p:sldIdLst>
   <p:notesMasterIdLst>
-    <p:notesMasterId r:id="rId6"/>
+    <p:notesMasterId r:id="rId8"/>
   </p:notesMasterIdLst>
   <p:sldSz cx="9144000" cy="5143500"/>
   <p:notesSz cx="5143500" cy="9144000"/>
@@ -811,6 +813,182 @@
 </p:notes>
 </file>
 
+<file path=ppt/notesSlides/notesSlide5.xml><?xml version="1.0" encoding="utf-8"?>
+<p:notes xmlns:a="http://schemas.openxmlformats.org/drawingml/2006/main" xmlns:r="http://schemas.openxmlformats.org/officeDocument/2006/relationships" xmlns:p="http://schemas.openxmlformats.org/presentationml/2006/main">
+  <p:cSld>
+    <p:spTree>
+      <p:nvGrpSpPr>
+        <p:cNvPr id="1" name=""/>
+        <p:cNvGrpSpPr/>
+        <p:nvPr/>
+      </p:nvGrpSpPr>
+      <p:grpSpPr>
+        <a:xfrm>
+          <a:off x="0" y="0"/>
+          <a:ext cx="0" cy="0"/>
+          <a:chOff x="0" y="0"/>
+          <a:chExt cx="0" cy="0"/>
+        </a:xfrm>
+      </p:grpSpPr>
+      <p:sp>
+        <p:nvSpPr>
+          <p:cNvPr id="2" name="Slide Image Placeholder 1"/>
+          <p:cNvSpPr>
+            <a:spLocks noGrp="1" noRot="1" noChangeAspect="1"/>
+          </p:cNvSpPr>
+          <p:nvPr>
+            <p:ph type="sldImg"/>
+          </p:nvPr>
+        </p:nvSpPr>
+        <p:spPr/>
+      </p:sp>
+      <p:sp>
+        <p:nvSpPr>
+          <p:cNvPr id="3" name="Notes Placeholder 2"/>
+          <p:cNvSpPr>
+            <a:spLocks noGrp="1"/>
+          </p:cNvSpPr>
+          <p:nvPr>
+            <p:ph type="body" idx="1"/>
+          </p:nvPr>
+        </p:nvSpPr>
+        <p:spPr/>
+        <p:txBody>
+          <a:bodyPr/>
+          <a:lstStyle/>
+          <a:p>
+            <a:r>
+              <a:rPr lang="en-US" dirty="0"/>
+              <a:t/>
+            </a:r>
+            <a:endParaRPr lang="en-US" dirty="0"/>
+          </a:p>
+        </p:txBody>
+      </p:sp>
+      <p:sp>
+        <p:nvSpPr>
+          <p:cNvPr id="4" name="Slide Number Placeholder 3"/>
+          <p:cNvSpPr>
+            <a:spLocks noGrp="1"/>
+          </p:cNvSpPr>
+          <p:nvPr>
+            <p:ph type="sldNum" sz="quarter" idx="10"/>
+          </p:nvPr>
+        </p:nvSpPr>
+        <p:spPr/>
+        <p:txBody>
+          <a:bodyPr/>
+          <a:lstStyle/>
+          <a:p>
+            <a:fld id="{F7021451-1387-4CA6-816F-3879F97B5CBC}" type="slidenum">
+              <a:rPr lang="en-US"/>
+              <a:t>5</a:t>
+            </a:fld>
+            <a:endParaRPr lang="en-US"/>
+          </a:p>
+        </p:txBody>
+      </p:sp>
+    </p:spTree>
+    <p:extLst>
+      <p:ext uri="{BB962C8B-B14F-4D97-AF65-F5344CB8AC3E}">
+        <p14:creationId xmlns:p14="http://schemas.microsoft.com/office/powerpoint/2010/main" val="1024086991"/>
+      </p:ext>
+    </p:extLst>
+  </p:cSld>
+  <p:clrMapOvr>
+    <a:masterClrMapping/>
+  </p:clrMapOvr>
+</p:notes>
+</file>
+
+<file path=ppt/notesSlides/notesSlide6.xml><?xml version="1.0" encoding="utf-8"?>
+<p:notes xmlns:a="http://schemas.openxmlformats.org/drawingml/2006/main" xmlns:r="http://schemas.openxmlformats.org/officeDocument/2006/relationships" xmlns:p="http://schemas.openxmlformats.org/presentationml/2006/main">
+  <p:cSld>
+    <p:spTree>
+      <p:nvGrpSpPr>
+        <p:cNvPr id="1" name=""/>
+        <p:cNvGrpSpPr/>
+        <p:nvPr/>
+      </p:nvGrpSpPr>
+      <p:grpSpPr>
+        <a:xfrm>
+          <a:off x="0" y="0"/>
+          <a:ext cx="0" cy="0"/>
+          <a:chOff x="0" y="0"/>
+          <a:chExt cx="0" cy="0"/>
+        </a:xfrm>
+      </p:grpSpPr>
+      <p:sp>
+        <p:nvSpPr>
+          <p:cNvPr id="2" name="Slide Image Placeholder 1"/>
+          <p:cNvSpPr>
+            <a:spLocks noGrp="1" noRot="1" noChangeAspect="1"/>
+          </p:cNvSpPr>
+          <p:nvPr>
+            <p:ph type="sldImg"/>
+          </p:nvPr>
+        </p:nvSpPr>
+        <p:spPr/>
+      </p:sp>
+      <p:sp>
+        <p:nvSpPr>
+          <p:cNvPr id="3" name="Notes Placeholder 2"/>
+          <p:cNvSpPr>
+            <a:spLocks noGrp="1"/>
+          </p:cNvSpPr>
+          <p:nvPr>
+            <p:ph type="body" idx="1"/>
+          </p:nvPr>
+        </p:nvSpPr>
+        <p:spPr/>
+        <p:txBody>
+          <a:bodyPr/>
+          <a:lstStyle/>
+          <a:p>
+            <a:r>
+              <a:rPr lang="en-US" dirty="0"/>
+              <a:t/>
+            </a:r>
+            <a:endParaRPr lang="en-US" dirty="0"/>
+          </a:p>
+        </p:txBody>
+      </p:sp>
+      <p:sp>
+        <p:nvSpPr>
+          <p:cNvPr id="4" name="Slide Number Placeholder 3"/>
+          <p:cNvSpPr>
+            <a:spLocks noGrp="1"/>
+          </p:cNvSpPr>
+          <p:nvPr>
+            <p:ph type="sldNum" sz="quarter" idx="10"/>
+          </p:nvPr>
+        </p:nvSpPr>
+        <p:spPr/>
+        <p:txBody>
+          <a:bodyPr/>
+          <a:lstStyle/>
+          <a:p>
+            <a:fld id="{F7021451-1387-4CA6-816F-3879F97B5CBC}" type="slidenum">
+              <a:rPr lang="en-US"/>
+              <a:t>6</a:t>
+            </a:fld>
+            <a:endParaRPr lang="en-US"/>
+          </a:p>
+        </p:txBody>
+      </p:sp>
+    </p:spTree>
+    <p:extLst>
+      <p:ext uri="{BB962C8B-B14F-4D97-AF65-F5344CB8AC3E}">
+        <p14:creationId xmlns:p14="http://schemas.microsoft.com/office/powerpoint/2010/main" val="1024086991"/>
+      </p:ext>
+    </p:extLst>
+  </p:cSld>
+  <p:clrMapOvr>
+    <a:masterClrMapping/>
+  </p:clrMapOvr>
+</p:notes>
+</file>
+
 <file path=ppt/slideLayouts/slideLayout1.xml><?xml version="1.0" encoding="utf-8"?>
 <p:sldLayout xmlns:a="http://schemas.openxmlformats.org/drawingml/2006/main" xmlns:r="http://schemas.openxmlformats.org/officeDocument/2006/relationships" xmlns:p="http://schemas.openxmlformats.org/presentationml/2006/main" preserve="1">
   <p:cSld name="DEFAULT">
@@ -841,6 +1019,101 @@
 </p:sldLayout>
 </file>
 
+<file path=ppt/slideLayouts/slideLayout2.xml><?xml version="1.0" encoding="utf-8"?>
+<p:sldLayout xmlns:a="http://schemas.openxmlformats.org/drawingml/2006/main" xmlns:r="http://schemas.openxmlformats.org/officeDocument/2006/relationships" xmlns:p="http://schemas.openxmlformats.org/presentationml/2006/main" preserve="1">
+  <p:cSld name="PLAIN">
+    <p:spTree>
+      <p:nvGrpSpPr>
+        <p:cNvPr id="1" name=""/>
+        <p:cNvGrpSpPr/>
+        <p:nvPr/>
+      </p:nvGrpSpPr>
+      <p:grpSpPr>
+        <a:xfrm>
+          <a:off x="0" y="0"/>
+          <a:ext cx="0" cy="0"/>
+          <a:chOff x="0" y="0"/>
+          <a:chExt cx="0" cy="0"/>
+        </a:xfrm>
+      </p:grpSpPr>
+      <p:sp>
+        <p:nvSpPr>
+          <p:cNvPr id="2" name="Text 0"/>
+          <p:cNvSpPr/>
+          <p:nvPr>
+            <p:ph idx="100" type="title" hasCustomPrompt="1"/>
+          </p:nvPr>
+        </p:nvSpPr>
+        <p:spPr>
+          <a:xfrm>
+            <a:off x="457200" y="274320"/>
+            <a:ext cx="8229600" cy="731520"/>
+          </a:xfrm>
+          <a:prstGeom prst="rect">
+            <a:avLst/>
+          </a:prstGeom>
+          <a:noFill/>
+          <a:ln/>
+        </p:spPr>
+        <p:txBody>
+          <a:bodyPr wrap="square" rtlCol="0"/>
+          <a:lstStyle>
+            <a:lvl1pPr indent="0" marL="0">
+              <a:buNone/>
+              <a:defRPr lang="en-US" dirty="0"/>
+            </a:lvl1pPr>
+          </a:lstStyle>
+          <a:p>
+            <a:pPr indent="0" marL="0">
+              <a:buNone/>
+            </a:pPr>
+            <a:endParaRPr lang="en-US" dirty="0"/>
+          </a:p>
+        </p:txBody>
+      </p:sp>
+      <p:sp>
+        <p:nvSpPr>
+          <p:cNvPr id="3" name="Text 0"/>
+          <p:cNvSpPr/>
+          <p:nvPr>
+            <p:ph idx="101" type="body" hasCustomPrompt="1"/>
+          </p:nvPr>
+        </p:nvSpPr>
+        <p:spPr>
+          <a:xfrm>
+            <a:off x="457200" y="1188720"/>
+            <a:ext cx="8229600" cy="2743200"/>
+          </a:xfrm>
+          <a:prstGeom prst="rect">
+            <a:avLst/>
+          </a:prstGeom>
+          <a:noFill/>
+          <a:ln/>
+        </p:spPr>
+        <p:txBody>
+          <a:bodyPr wrap="square" rtlCol="0"/>
+          <a:lstStyle>
+            <a:lvl1pPr indent="0" marL="0">
+              <a:buNone/>
+              <a:defRPr lang="en-US" dirty="0"/>
+            </a:lvl1pPr>
+          </a:lstStyle>
+          <a:p>
+            <a:pPr indent="0" marL="0">
+              <a:buNone/>
+            </a:pPr>
+            <a:endParaRPr lang="en-US" dirty="0"/>
+          </a:p>
+        </p:txBody>
+      </p:sp>
+    </p:spTree>
+  </p:cSld>
+  <p:clrMapOvr>
+    <a:masterClrMapping/>
+  </p:clrMapOvr>
+</p:sldLayout>
+</file>
+
 <file path=ppt/slideMasters/slideMaster1.xml><?xml version="1.0" encoding="utf-8"?>
 <p:sldMaster xmlns:a="http://schemas.openxmlformats.org/drawingml/2006/main" xmlns:r="http://schemas.openxmlformats.org/officeDocument/2006/relationships" xmlns:p="http://schemas.openxmlformats.org/presentationml/2006/main">
   <p:cSld>
@@ -863,6 +1136,7 @@
   <p:clrMap bg1="lt1" tx1="dk1" bg2="lt2" tx2="dk2" accent1="accent1" accent2="accent2" accent3="accent3" accent4="accent4" accent5="accent5" accent6="accent6" hlink="hlink" folHlink="folHlink"/>
   <p:sldLayoutIdLst>
     <p:sldLayoutId id="2147483649" r:id="rId1"/>
+    <p:sldLayoutId id="2147483650" r:id="rId2"/>
   </p:sldLayoutIdLst>
   <p:hf sldNum="0" hdr="0" ftr="0" dt="0"/>
   <p:txStyles>
@@ -1551,6 +1825,329 @@
           <a:chExt cx="0" cy="0"/>
         </a:xfrm>
       </p:grpSpPr>
+    </p:spTree>
+  </p:cSld>
+  <p:clrMapOvr>
+    <a:masterClrMapping/>
+  </p:clrMapOvr>
+</p:sld>
+</file>
+
+<file path=ppt/slides/slide5.xml><?xml version="1.0" encoding="utf-8"?>
+<p:sld xmlns:a="http://schemas.openxmlformats.org/drawingml/2006/main" xmlns:r="http://schemas.openxmlformats.org/officeDocument/2006/relationships" xmlns:p="http://schemas.openxmlformats.org/presentationml/2006/main">
+  <p:cSld name="Slide 5">
+    <p:spTree>
+      <p:nvGrpSpPr>
+        <p:cNvPr id="1" name=""/>
+        <p:cNvGrpSpPr/>
+        <p:nvPr/>
+      </p:nvGrpSpPr>
+      <p:grpSpPr>
+        <a:xfrm>
+          <a:off x="0" y="0"/>
+          <a:ext cx="0" cy="0"/>
+          <a:chOff x="0" y="0"/>
+          <a:chExt cx="0" cy="0"/>
+        </a:xfrm>
+      </p:grpSpPr>
+      <p:sp>
+        <p:nvSpPr>
+          <p:cNvPr id="2" name="Text 0"/>
+          <p:cNvSpPr/>
+          <p:nvPr>
+            <p:ph idx="100" type="title" hasCustomPrompt="1"/>
+          </p:nvPr>
+        </p:nvSpPr>
+        <p:spPr>
+          <a:xfrm>
+            <a:off x="457200" y="274320"/>
+            <a:ext cx="8229600" cy="731520"/>
+          </a:xfrm>
+          <a:prstGeom prst="rect">
+            <a:avLst/>
+          </a:prstGeom>
+          <a:noFill/>
+          <a:ln/>
+        </p:spPr>
+        <p:txBody>
+          <a:bodyPr wrap="square" rtlCol="0"/>
+          <a:lstStyle/>
+          <a:p>
+            <a:pPr indent="0" marL="0">
+              <a:buNone/>
+            </a:pPr>
+            <a:r>
+              <a:rPr lang="en-US" dirty="0"/>
+              <a:t>Risks</a:t>
+            </a:r>
+            <a:endParaRPr lang="en-US" dirty="0"/>
+          </a:p>
+        </p:txBody>
+      </p:sp>
+      <p:sp>
+        <p:nvSpPr>
+          <p:cNvPr id="3" name="Text 0"/>
+          <p:cNvSpPr/>
+          <p:nvPr>
+            <p:ph idx="101" type="body" hasCustomPrompt="1"/>
+          </p:nvPr>
+        </p:nvSpPr>
+        <p:spPr>
+          <a:xfrm>
+            <a:off x="457200" y="1188720"/>
+            <a:ext cx="8229600" cy="2743200"/>
+          </a:xfrm>
+          <a:prstGeom prst="rect">
+            <a:avLst/>
+          </a:prstGeom>
+          <a:noFill/>
+          <a:ln/>
+        </p:spPr>
+        <p:txBody>
+          <a:bodyPr wrap="square" rtlCol="0"/>
+          <a:lstStyle/>
+          <a:p>
+            <a:pPr indent="0" marL="0"/>
+            <a:r>
+              <a:rPr lang="en-US" dirty="0">
+                <a:solidFill>
+                  <a:srgbClr val="000000"/>
+                </a:solidFill>
+              </a:rPr>
+              <a:t>Supplier delays</a:t>
+            </a:r>
+            <a:endParaRPr lang="en-US" dirty="0"/>
+          </a:p>
+          <a:p>
+            <a:pPr lvl="1" indent="0" marL="0"/>
+            <a:r>
+              <a:rPr lang="en-US" dirty="0">
+                <a:solidFill>
+                  <a:srgbClr val="000000"/>
+                </a:solidFill>
+              </a:rPr>
+              <a:t>Two plants affected</a:t>
+            </a:r>
+            <a:endParaRPr lang="en-US" dirty="0"/>
+          </a:p>
+          <a:p>
+            <a:pPr indent="0" marL="0">
+              <a:buNone/>
+            </a:pPr>
+            <a:r>
+              <a:rPr lang="en-US" dirty="0">
+                <a:solidFill>
+                  <a:srgbClr val="000000"/>
+                </a:solidFill>
+              </a:rPr>
+              <a:t>Mitigation is in the appendix.</a:t>
+            </a:r>
+            <a:endParaRPr lang="en-US" dirty="0"/>
+          </a:p>
+        </p:txBody>
+      </p:sp>
+    </p:spTree>
+  </p:cSld>
+  <p:clrMapOvr>
+    <a:masterClrMapping/>
+  </p:clrMapOvr>
+</p:sld>
+</file>
+
+<file path=ppt/slides/slide6.xml><?xml version="1.0" encoding="utf-8"?>
+<p:sld xmlns:a="http://schemas.openxmlformats.org/drawingml/2006/main" xmlns:r="http://schemas.openxmlformats.org/officeDocument/2006/relationships" xmlns:p="http://schemas.openxmlformats.org/presentationml/2006/main">
+  <p:cSld name="Slide 6">
+    <p:spTree>
+      <p:nvGrpSpPr>
+        <p:cNvPr id="1" name=""/>
+        <p:cNvGrpSpPr/>
+        <p:nvPr/>
+      </p:nvGrpSpPr>
+      <p:grpSpPr>
+        <a:xfrm>
+          <a:off x="0" y="0"/>
+          <a:ext cx="0" cy="0"/>
+          <a:chOff x="0" y="0"/>
+          <a:chExt cx="0" cy="0"/>
+        </a:xfrm>
+      </p:grpSpPr>
+      <p:sp>
+        <p:nvSpPr>
+          <p:cNvPr id="2" name="Text 0"/>
+          <p:cNvSpPr/>
+          <p:nvPr/>
+        </p:nvSpPr>
+        <p:spPr>
+          <a:xfrm>
+            <a:off x="457200" y="91440"/>
+            <a:ext cx="8229600" cy="274320"/>
+          </a:xfrm>
+          <a:prstGeom prst="rect">
+            <a:avLst/>
+          </a:prstGeom>
+          <a:noFill/>
+          <a:ln/>
+        </p:spPr>
+        <p:txBody>
+          <a:bodyPr wrap="square" rtlCol="0" anchor="ctr"/>
+          <a:lstStyle/>
+          <a:p>
+            <a:pPr indent="0" marL="0">
+              <a:buNone/>
+            </a:pPr>
+            <a:r>
+              <a:rPr lang="en-US" sz="1000" dirty="0">
+                <a:solidFill>
+                  <a:srgbClr val="000000"/>
+                </a:solidFill>
+              </a:rPr>
+              <a:t>Small print at the top</a:t>
+            </a:r>
+            <a:endParaRPr lang="en-US" sz="1000" dirty="0"/>
+          </a:p>
+        </p:txBody>
+      </p:sp>
+      <p:sp>
+        <p:nvSpPr>
+          <p:cNvPr id="3" name="Text 1"/>
+          <p:cNvSpPr/>
+          <p:nvPr/>
+        </p:nvSpPr>
+        <p:spPr>
+          <a:xfrm>
+            <a:off x="457200" y="457200"/>
+            <a:ext cx="8229600" cy="731520"/>
+          </a:xfrm>
+          <a:prstGeom prst="rect">
+            <a:avLst/>
+          </a:prstGeom>
+          <a:noFill/>
+          <a:ln/>
+        </p:spPr>
+        <p:txBody>
+          <a:bodyPr wrap="square" rtlCol="0" anchor="ctr"/>
+          <a:lstStyle/>
+          <a:p>
+            <a:pPr indent="0" marL="0">
+              <a:buNone/>
+            </a:pPr>
+            <a:r>
+              <a:rPr lang="en-US" sz="2800" dirty="0">
+                <a:solidFill>
+                  <a:srgbClr val="000000"/>
+                </a:solidFill>
+              </a:rPr>
+              <a:t>Plan for Q4</a:t>
+            </a:r>
+            <a:endParaRPr lang="en-US" sz="2800" dirty="0"/>
+          </a:p>
+        </p:txBody>
+      </p:sp>
+      <p:sp>
+        <p:nvSpPr>
+          <p:cNvPr id="4" name="Text 2"/>
+          <p:cNvSpPr/>
+          <p:nvPr/>
+        </p:nvSpPr>
+        <p:spPr>
+          <a:xfrm>
+            <a:off x="457200" y="1371600"/>
+            <a:ext cx="8229600" cy="1828800"/>
+          </a:xfrm>
+          <a:prstGeom prst="rect">
+            <a:avLst/>
+          </a:prstGeom>
+          <a:noFill/>
+          <a:ln/>
+        </p:spPr>
+        <p:txBody>
+          <a:bodyPr wrap="square" rtlCol="0" anchor="ctr"/>
+          <a:lstStyle/>
+          <a:p>
+            <a:pPr marL="342900" indent="-342900">
+              <a:buSzPct val="100000"/>
+              <a:buFont typeface="+mj-lt"/>
+              <a:buAutoNum type="arabicPeriod" startAt="1"/>
+            </a:pPr>
+            <a:r>
+              <a:rPr lang="en-US" dirty="0">
+                <a:solidFill>
+                  <a:srgbClr val="000000"/>
+                </a:solidFill>
+              </a:rPr>
+              <a:t>Close the lease</a:t>
+            </a:r>
+            <a:endParaRPr lang="en-US" dirty="0"/>
+          </a:p>
+          <a:p>
+            <a:pPr lvl="1" marL="685800" indent="-342900">
+              <a:buSzPct val="100000"/>
+              <a:buChar char="•"/>
+            </a:pPr>
+            <a:r>
+              <a:rPr lang="en-US" dirty="0">
+                <a:solidFill>
+                  <a:srgbClr val="000000"/>
+                </a:solidFill>
+              </a:rPr>
+              <a:t>Notice by October</a:t>
+            </a:r>
+            <a:endParaRPr lang="en-US" dirty="0"/>
+          </a:p>
+          <a:p>
+            <a:pPr marL="342900" indent="-342900">
+              <a:buSzPct val="100000"/>
+              <a:buFont typeface="+mj-lt"/>
+              <a:buAutoNum type="arabicPeriod" startAt="1"/>
+            </a:pPr>
+            <a:r>
+              <a:rPr lang="en-US" dirty="0">
+                <a:solidFill>
+                  <a:srgbClr val="000000"/>
+                </a:solidFill>
+              </a:rPr>
+              <a:t>Hire support</a:t>
+            </a:r>
+            <a:endParaRPr lang="en-US" dirty="0"/>
+          </a:p>
+        </p:txBody>
+      </p:sp>
+      <p:sp>
+        <p:nvSpPr>
+          <p:cNvPr id="5" name="Text 3"/>
+          <p:cNvSpPr/>
+          <p:nvPr/>
+        </p:nvSpPr>
+        <p:spPr>
+          <a:xfrm>
+            <a:off x="457200" y="3657600"/>
+            <a:ext cx="8229600" cy="457200"/>
+          </a:xfrm>
+          <a:prstGeom prst="rect">
+            <a:avLst/>
+          </a:prstGeom>
+          <a:noFill/>
+          <a:ln/>
+        </p:spPr>
+        <p:txBody>
+          <a:bodyPr wrap="square" rtlCol="0" anchor="ctr"/>
+          <a:lstStyle/>
+          <a:p>
+            <a:pPr indent="0" marL="0">
+              <a:buNone/>
+            </a:pPr>
+            <a:r>
+              <a:rPr lang="en-US" sz="1200" dirty="0">
+                <a:solidFill>
+                  <a:srgbClr val="000000"/>
+                </a:solidFill>
+              </a:rPr>
+              <a:t>Figures are estimates.</a:t>
+            </a:r>
+            <a:endParaRPr lang="en-US" sz="1200" dirty="0"/>
+          </a:p>
+        </p:txBody>
+      </p:sp>
     </p:spTree>
   </p:cSld>
   <p:clrMapOvr>

</xml_diff>